<commit_message>
Update lesson 5-6 decks and notebooks
Lesson 6: clearer observed histogram on prior predictive slide,
linear-scale Student-t densities on slide 15.

Co-Authored-By: Claude Opus 5.5 <noreply@anthropic.com>
</commit_message>
<xml_diff>
--- a/presenations/Bayesian models les5.pptx
+++ b/presenations/Bayesian models les5.pptx
@@ -1211,7 +1211,7 @@
           <a:p>
             <a:fld id="{5BCAD085-E8A6-8845-BD4E-CB4CCA059FC4}" type="datetimeFigureOut">
               <a:rPr lang="en-US" smtClean="0"/>
-              <a:t>10/13/2026</a:t>
+              <a:t>10/25/2026</a:t>
             </a:fld>
             <a:endParaRPr lang="en-US"/>
           </a:p>
@@ -1379,7 +1379,7 @@
           <a:p>
             <a:fld id="{5BCAD085-E8A6-8845-BD4E-CB4CCA059FC4}" type="datetimeFigureOut">
               <a:rPr lang="en-US" smtClean="0"/>
-              <a:t>10/13/2026</a:t>
+              <a:t>10/25/2026</a:t>
             </a:fld>
             <a:endParaRPr lang="en-US"/>
           </a:p>
@@ -1557,7 +1557,7 @@
           <a:p>
             <a:fld id="{5BCAD085-E8A6-8845-BD4E-CB4CCA059FC4}" type="datetimeFigureOut">
               <a:rPr lang="en-US" smtClean="0"/>
-              <a:t>10/13/2026</a:t>
+              <a:t>10/25/2026</a:t>
             </a:fld>
             <a:endParaRPr lang="en-US"/>
           </a:p>
@@ -1725,7 +1725,7 @@
           <a:p>
             <a:fld id="{5BCAD085-E8A6-8845-BD4E-CB4CCA059FC4}" type="datetimeFigureOut">
               <a:rPr lang="en-US" smtClean="0"/>
-              <a:t>10/13/2026</a:t>
+              <a:t>10/25/2026</a:t>
             </a:fld>
             <a:endParaRPr lang="en-US"/>
           </a:p>
@@ -1970,7 +1970,7 @@
           <a:p>
             <a:fld id="{5BCAD085-E8A6-8845-BD4E-CB4CCA059FC4}" type="datetimeFigureOut">
               <a:rPr lang="en-US" smtClean="0"/>
-              <a:t>10/13/2026</a:t>
+              <a:t>10/25/2026</a:t>
             </a:fld>
             <a:endParaRPr lang="en-US"/>
           </a:p>
@@ -2255,7 +2255,7 @@
           <a:p>
             <a:fld id="{5BCAD085-E8A6-8845-BD4E-CB4CCA059FC4}" type="datetimeFigureOut">
               <a:rPr lang="en-US" smtClean="0"/>
-              <a:t>10/13/2026</a:t>
+              <a:t>10/25/2026</a:t>
             </a:fld>
             <a:endParaRPr lang="en-US"/>
           </a:p>
@@ -2674,7 +2674,7 @@
           <a:p>
             <a:fld id="{5BCAD085-E8A6-8845-BD4E-CB4CCA059FC4}" type="datetimeFigureOut">
               <a:rPr lang="en-US" smtClean="0"/>
-              <a:t>10/13/2026</a:t>
+              <a:t>10/25/2026</a:t>
             </a:fld>
             <a:endParaRPr lang="en-US"/>
           </a:p>
@@ -2791,7 +2791,7 @@
           <a:p>
             <a:fld id="{5BCAD085-E8A6-8845-BD4E-CB4CCA059FC4}" type="datetimeFigureOut">
               <a:rPr lang="en-US" smtClean="0"/>
-              <a:t>10/13/2026</a:t>
+              <a:t>10/25/2026</a:t>
             </a:fld>
             <a:endParaRPr lang="en-US"/>
           </a:p>
@@ -2886,7 +2886,7 @@
           <a:p>
             <a:fld id="{5BCAD085-E8A6-8845-BD4E-CB4CCA059FC4}" type="datetimeFigureOut">
               <a:rPr lang="en-US" smtClean="0"/>
-              <a:t>10/13/2026</a:t>
+              <a:t>10/25/2026</a:t>
             </a:fld>
             <a:endParaRPr lang="en-US"/>
           </a:p>
@@ -3161,7 +3161,7 @@
           <a:p>
             <a:fld id="{5BCAD085-E8A6-8845-BD4E-CB4CCA059FC4}" type="datetimeFigureOut">
               <a:rPr lang="en-US" smtClean="0"/>
-              <a:t>10/13/2026</a:t>
+              <a:t>10/25/2026</a:t>
             </a:fld>
             <a:endParaRPr lang="en-US"/>
           </a:p>
@@ -3413,7 +3413,7 @@
           <a:p>
             <a:fld id="{5BCAD085-E8A6-8845-BD4E-CB4CCA059FC4}" type="datetimeFigureOut">
               <a:rPr lang="en-US" smtClean="0"/>
-              <a:t>10/13/2026</a:t>
+              <a:t>10/25/2026</a:t>
             </a:fld>
             <a:endParaRPr lang="en-US"/>
           </a:p>
@@ -3624,7 +3624,7 @@
           <a:p>
             <a:fld id="{5BCAD085-E8A6-8845-BD4E-CB4CCA059FC4}" type="datetimeFigureOut">
               <a:rPr lang="en-US" smtClean="0"/>
-              <a:t>10/13/2026</a:t>
+              <a:t>10/25/2026</a:t>
             </a:fld>
             <a:endParaRPr lang="en-US"/>
           </a:p>
@@ -4009,222 +4009,6 @@
       </p:grpSpPr>
       <p:sp>
         <p:nvSpPr>
-          <p:cNvPr id="2" name="badge ה"/>
-          <p:cNvSpPr/>
-          <p:nvPr/>
-        </p:nvSpPr>
-        <p:spPr>
-          <a:xfrm>
-            <a:off x="822960" y="5120640"/>
-            <a:ext cx="868680" cy="868680"/>
-          </a:xfrm>
-          <a:prstGeom prst="ellipse">
-            <a:avLst/>
-          </a:prstGeom>
-          <a:solidFill>
-            <a:srgbClr val="17A398"/>
-          </a:solidFill>
-          <a:ln>
-            <a:noFill/>
-          </a:ln>
-          <a:effectLst/>
-        </p:spPr>
-        <p:style>
-          <a:lnRef idx="1">
-            <a:schemeClr val="accent1"/>
-          </a:lnRef>
-          <a:fillRef idx="3">
-            <a:schemeClr val="accent1"/>
-          </a:fillRef>
-          <a:effectRef idx="2">
-            <a:schemeClr val="accent1"/>
-          </a:effectRef>
-          <a:fontRef idx="minor">
-            <a:schemeClr val="lt1"/>
-          </a:fontRef>
-        </p:style>
-        <p:txBody>
-          <a:bodyPr wrap="square" lIns="0" tIns="0" rIns="0" bIns="0" rtlCol="0" anchor="ctr"/>
-          <a:lstStyle/>
-          <a:p>
-            <a:pPr algn="ctr"/>
-            <a:r>
-              <a:rPr sz="2600" b="1">
-                <a:solidFill>
-                  <a:srgbClr val="FFFFFF"/>
-                </a:solidFill>
-                <a:latin typeface="Arial"/>
-                <a:cs typeface="Arial"/>
-              </a:rPr>
-              <a:t>ה</a:t>
-            </a:r>
-          </a:p>
-        </p:txBody>
-      </p:sp>
-      <p:sp>
-        <p:nvSpPr>
-          <p:cNvPr id="3" name="badge ו"/>
-          <p:cNvSpPr/>
-          <p:nvPr/>
-        </p:nvSpPr>
-        <p:spPr>
-          <a:xfrm>
-            <a:off x="1874519" y="5120640"/>
-            <a:ext cx="868680" cy="868680"/>
-          </a:xfrm>
-          <a:prstGeom prst="ellipse">
-            <a:avLst/>
-          </a:prstGeom>
-          <a:solidFill>
-            <a:srgbClr val="7B5EA7"/>
-          </a:solidFill>
-          <a:ln>
-            <a:noFill/>
-          </a:ln>
-          <a:effectLst/>
-        </p:spPr>
-        <p:style>
-          <a:lnRef idx="1">
-            <a:schemeClr val="accent1"/>
-          </a:lnRef>
-          <a:fillRef idx="3">
-            <a:schemeClr val="accent1"/>
-          </a:fillRef>
-          <a:effectRef idx="2">
-            <a:schemeClr val="accent1"/>
-          </a:effectRef>
-          <a:fontRef idx="minor">
-            <a:schemeClr val="lt1"/>
-          </a:fontRef>
-        </p:style>
-        <p:txBody>
-          <a:bodyPr wrap="square" lIns="0" tIns="0" rIns="0" bIns="0" rtlCol="0" anchor="ctr"/>
-          <a:lstStyle/>
-          <a:p>
-            <a:pPr algn="ctr"/>
-            <a:r>
-              <a:rPr sz="2600" b="1">
-                <a:solidFill>
-                  <a:srgbClr val="FFFFFF"/>
-                </a:solidFill>
-                <a:latin typeface="Arial"/>
-                <a:cs typeface="Arial"/>
-              </a:rPr>
-              <a:t>ו</a:t>
-            </a:r>
-          </a:p>
-        </p:txBody>
-      </p:sp>
-      <p:sp>
-        <p:nvSpPr>
-          <p:cNvPr id="4" name="badge ש"/>
-          <p:cNvSpPr/>
-          <p:nvPr/>
-        </p:nvSpPr>
-        <p:spPr>
-          <a:xfrm>
-            <a:off x="2926079" y="5120640"/>
-            <a:ext cx="868680" cy="868680"/>
-          </a:xfrm>
-          <a:prstGeom prst="ellipse">
-            <a:avLst/>
-          </a:prstGeom>
-          <a:solidFill>
-            <a:srgbClr val="E4572E"/>
-          </a:solidFill>
-          <a:ln>
-            <a:noFill/>
-          </a:ln>
-          <a:effectLst/>
-        </p:spPr>
-        <p:style>
-          <a:lnRef idx="1">
-            <a:schemeClr val="accent1"/>
-          </a:lnRef>
-          <a:fillRef idx="3">
-            <a:schemeClr val="accent1"/>
-          </a:fillRef>
-          <a:effectRef idx="2">
-            <a:schemeClr val="accent1"/>
-          </a:effectRef>
-          <a:fontRef idx="minor">
-            <a:schemeClr val="lt1"/>
-          </a:fontRef>
-        </p:style>
-        <p:txBody>
-          <a:bodyPr wrap="square" lIns="0" tIns="0" rIns="0" bIns="0" rtlCol="0" anchor="ctr"/>
-          <a:lstStyle/>
-          <a:p>
-            <a:pPr algn="ctr"/>
-            <a:r>
-              <a:rPr sz="2600" b="1">
-                <a:solidFill>
-                  <a:srgbClr val="FFFFFF"/>
-                </a:solidFill>
-                <a:latin typeface="Arial"/>
-                <a:cs typeface="Arial"/>
-              </a:rPr>
-              <a:t>ש</a:t>
-            </a:r>
-          </a:p>
-        </p:txBody>
-      </p:sp>
-      <p:sp>
-        <p:nvSpPr>
-          <p:cNvPr id="5" name="badge א"/>
-          <p:cNvSpPr/>
-          <p:nvPr/>
-        </p:nvSpPr>
-        <p:spPr>
-          <a:xfrm>
-            <a:off x="3977639" y="5120640"/>
-            <a:ext cx="868680" cy="868680"/>
-          </a:xfrm>
-          <a:prstGeom prst="ellipse">
-            <a:avLst/>
-          </a:prstGeom>
-          <a:solidFill>
-            <a:srgbClr val="CFC6DE"/>
-          </a:solidFill>
-          <a:ln>
-            <a:noFill/>
-          </a:ln>
-          <a:effectLst/>
-        </p:spPr>
-        <p:style>
-          <a:lnRef idx="1">
-            <a:schemeClr val="accent1"/>
-          </a:lnRef>
-          <a:fillRef idx="3">
-            <a:schemeClr val="accent1"/>
-          </a:fillRef>
-          <a:effectRef idx="2">
-            <a:schemeClr val="accent1"/>
-          </a:effectRef>
-          <a:fontRef idx="minor">
-            <a:schemeClr val="lt1"/>
-          </a:fontRef>
-        </p:style>
-        <p:txBody>
-          <a:bodyPr wrap="square" lIns="0" tIns="0" rIns="0" bIns="0" rtlCol="0" anchor="ctr"/>
-          <a:lstStyle/>
-          <a:p>
-            <a:pPr algn="ctr"/>
-            <a:r>
-              <a:rPr sz="2600" b="1">
-                <a:solidFill>
-                  <a:srgbClr val="FFFFFF"/>
-                </a:solidFill>
-                <a:latin typeface="Arial"/>
-                <a:cs typeface="Arial"/>
-              </a:rPr>
-              <a:t>א</a:t>
-            </a:r>
-          </a:p>
-        </p:txBody>
-      </p:sp>
-      <p:sp>
-        <p:nvSpPr>
           <p:cNvPr id="6" name="Title"/>
           <p:cNvSpPr txBox="1"/>
           <p:nvPr/>
@@ -8689,7 +8473,7 @@
               <a:buChar char="•"/>
             </a:pPr>
             <a:r>
-              <a:rPr lang="he-IL" sz="1600" b="1" i="0">
+              <a:rPr lang="he-IL" sz="1600" b="1" i="0" dirty="0">
                 <a:solidFill>
                   <a:srgbClr val="2B1E3F"/>
                 </a:solidFill>
@@ -8699,7 +8483,7 @@
               <a:t>idx</a:t>
             </a:r>
             <a:r>
-              <a:rPr lang="he-IL" sz="1600" b="0" i="0">
+              <a:rPr lang="he-IL" sz="1600" b="0" i="0" dirty="0">
                 <a:solidFill>
                   <a:srgbClr val="2B1E3F"/>
                 </a:solidFill>
@@ -8721,7 +8505,7 @@
               <a:buChar char="•"/>
             </a:pPr>
             <a:r>
-              <a:rPr lang="en-US" sz="1600" b="1" i="0">
+              <a:rPr lang="en-US" sz="1600" b="1" i="0" dirty="0">
                 <a:solidFill>
                   <a:srgbClr val="2B1E3F"/>
                 </a:solidFill>
@@ -8731,7 +8515,7 @@
               <a:t>μ</a:t>
             </a:r>
             <a:r>
-              <a:rPr lang="he-IL" sz="1600" b="1" i="0">
+              <a:rPr lang="he-IL" sz="1600" b="1" i="0" dirty="0">
                 <a:solidFill>
                   <a:srgbClr val="2B1E3F"/>
                 </a:solidFill>
@@ -8741,7 +8525,7 @@
               <a:t>[idx]</a:t>
             </a:r>
             <a:r>
-              <a:rPr lang="he-IL" sz="1600" b="0" i="0">
+              <a:rPr lang="he-IL" sz="1600" b="0" i="0" dirty="0">
                 <a:solidFill>
                   <a:srgbClr val="2B1E3F"/>
                 </a:solidFill>
@@ -8763,7 +8547,7 @@
               <a:buChar char="•"/>
             </a:pPr>
             <a:r>
-              <a:rPr lang="he-IL" sz="1600" b="0" i="0">
+              <a:rPr lang="he-IL" sz="1600" b="0" i="0" dirty="0">
                 <a:solidFill>
                   <a:srgbClr val="2B1E3F"/>
                 </a:solidFill>
@@ -8785,7 +8569,7 @@
               <a:buChar char="•"/>
             </a:pPr>
             <a:r>
-              <a:rPr lang="he-IL" sz="1600" b="1" i="0">
+              <a:rPr lang="he-IL" sz="1600" b="1" i="0" dirty="0">
                 <a:solidFill>
                   <a:srgbClr val="2B1E3F"/>
                 </a:solidFill>
@@ -8795,7 +8579,7 @@
               <a:t>categories[idx]</a:t>
             </a:r>
             <a:r>
-              <a:rPr lang="he-IL" sz="1600" b="0" i="0">
+              <a:rPr lang="he-IL" sz="1600" b="0" i="0" dirty="0">
                 <a:solidFill>
                   <a:srgbClr val="2B1E3F"/>
                 </a:solidFill>

</xml_diff>